<commit_message>
wrangling economic scenario data
</commit_message>
<xml_diff>
--- a/publication/lulcc_ch_visualisations.pptx
+++ b/publication/lulcc_ch_visualisations.pptx
@@ -6,6 +6,7 @@
   </p:sldMasterIdLst>
   <p:sldIdLst>
     <p:sldId id="257" r:id="rId2"/>
+    <p:sldId id="258" r:id="rId3"/>
   </p:sldIdLst>
   <p:sldSz cx="9906000" cy="6858000" type="A4"/>
   <p:notesSz cx="6858000" cy="9144000"/>
@@ -112,6 +113,11 @@
             <p14:sldId id="257"/>
           </p14:sldIdLst>
         </p14:section>
+        <p14:section name="Figure_1_V2" id="{88CEF7F3-5306-4F60-8BAE-61A82305E89F}">
+          <p14:sldIdLst>
+            <p14:sldId id="258"/>
+          </p14:sldIdLst>
+        </p14:section>
       </p14:sectionLst>
     </p:ext>
     <p:ext uri="{EFAFB233-063F-42B5-8137-9DF3F51BA10A}">
@@ -252,7 +258,7 @@
           <a:p>
             <a:fld id="{38A02E74-1BEC-4682-B539-13A15FE70A36}" type="datetimeFigureOut">
               <a:rPr lang="en-GB" smtClean="0"/>
-              <a:t>07/10/2022</a:t>
+              <a:t>25/11/2022</a:t>
             </a:fld>
             <a:endParaRPr lang="en-GB"/>
           </a:p>
@@ -422,7 +428,7 @@
           <a:p>
             <a:fld id="{38A02E74-1BEC-4682-B539-13A15FE70A36}" type="datetimeFigureOut">
               <a:rPr lang="en-GB" smtClean="0"/>
-              <a:t>07/10/2022</a:t>
+              <a:t>25/11/2022</a:t>
             </a:fld>
             <a:endParaRPr lang="en-GB"/>
           </a:p>
@@ -602,7 +608,7 @@
           <a:p>
             <a:fld id="{38A02E74-1BEC-4682-B539-13A15FE70A36}" type="datetimeFigureOut">
               <a:rPr lang="en-GB" smtClean="0"/>
-              <a:t>07/10/2022</a:t>
+              <a:t>25/11/2022</a:t>
             </a:fld>
             <a:endParaRPr lang="en-GB"/>
           </a:p>
@@ -772,7 +778,7 @@
           <a:p>
             <a:fld id="{38A02E74-1BEC-4682-B539-13A15FE70A36}" type="datetimeFigureOut">
               <a:rPr lang="en-GB" smtClean="0"/>
-              <a:t>07/10/2022</a:t>
+              <a:t>25/11/2022</a:t>
             </a:fld>
             <a:endParaRPr lang="en-GB"/>
           </a:p>
@@ -1016,7 +1022,7 @@
           <a:p>
             <a:fld id="{38A02E74-1BEC-4682-B539-13A15FE70A36}" type="datetimeFigureOut">
               <a:rPr lang="en-GB" smtClean="0"/>
-              <a:t>07/10/2022</a:t>
+              <a:t>25/11/2022</a:t>
             </a:fld>
             <a:endParaRPr lang="en-GB"/>
           </a:p>
@@ -1248,7 +1254,7 @@
           <a:p>
             <a:fld id="{38A02E74-1BEC-4682-B539-13A15FE70A36}" type="datetimeFigureOut">
               <a:rPr lang="en-GB" smtClean="0"/>
-              <a:t>07/10/2022</a:t>
+              <a:t>25/11/2022</a:t>
             </a:fld>
             <a:endParaRPr lang="en-GB"/>
           </a:p>
@@ -1615,7 +1621,7 @@
           <a:p>
             <a:fld id="{38A02E74-1BEC-4682-B539-13A15FE70A36}" type="datetimeFigureOut">
               <a:rPr lang="en-GB" smtClean="0"/>
-              <a:t>07/10/2022</a:t>
+              <a:t>25/11/2022</a:t>
             </a:fld>
             <a:endParaRPr lang="en-GB"/>
           </a:p>
@@ -1733,7 +1739,7 @@
           <a:p>
             <a:fld id="{38A02E74-1BEC-4682-B539-13A15FE70A36}" type="datetimeFigureOut">
               <a:rPr lang="en-GB" smtClean="0"/>
-              <a:t>07/10/2022</a:t>
+              <a:t>25/11/2022</a:t>
             </a:fld>
             <a:endParaRPr lang="en-GB"/>
           </a:p>
@@ -1828,7 +1834,7 @@
           <a:p>
             <a:fld id="{38A02E74-1BEC-4682-B539-13A15FE70A36}" type="datetimeFigureOut">
               <a:rPr lang="en-GB" smtClean="0"/>
-              <a:t>07/10/2022</a:t>
+              <a:t>25/11/2022</a:t>
             </a:fld>
             <a:endParaRPr lang="en-GB"/>
           </a:p>
@@ -2105,7 +2111,7 @@
           <a:p>
             <a:fld id="{38A02E74-1BEC-4682-B539-13A15FE70A36}" type="datetimeFigureOut">
               <a:rPr lang="en-GB" smtClean="0"/>
-              <a:t>07/10/2022</a:t>
+              <a:t>25/11/2022</a:t>
             </a:fld>
             <a:endParaRPr lang="en-GB"/>
           </a:p>
@@ -2362,7 +2368,7 @@
           <a:p>
             <a:fld id="{38A02E74-1BEC-4682-B539-13A15FE70A36}" type="datetimeFigureOut">
               <a:rPr lang="en-GB" smtClean="0"/>
-              <a:t>07/10/2022</a:t>
+              <a:t>25/11/2022</a:t>
             </a:fld>
             <a:endParaRPr lang="en-GB"/>
           </a:p>
@@ -2575,7 +2581,7 @@
           <a:p>
             <a:fld id="{38A02E74-1BEC-4682-B539-13A15FE70A36}" type="datetimeFigureOut">
               <a:rPr lang="en-GB" smtClean="0"/>
-              <a:t>07/10/2022</a:t>
+              <a:t>25/11/2022</a:t>
             </a:fld>
             <a:endParaRPr lang="en-GB"/>
           </a:p>
@@ -4404,6 +4410,1539 @@
 </p:sld>
 </file>
 
+<file path=ppt/slides/slide2.xml><?xml version="1.0" encoding="utf-8"?>
+<p:sld xmlns:a="http://schemas.openxmlformats.org/drawingml/2006/main" xmlns:r="http://schemas.openxmlformats.org/officeDocument/2006/relationships" xmlns:p="http://schemas.openxmlformats.org/presentationml/2006/main">
+  <p:cSld>
+    <p:spTree>
+      <p:nvGrpSpPr>
+        <p:cNvPr id="1" name=""/>
+        <p:cNvGrpSpPr/>
+        <p:nvPr/>
+      </p:nvGrpSpPr>
+      <p:grpSpPr>
+        <a:xfrm>
+          <a:off x="0" y="0"/>
+          <a:ext cx="0" cy="0"/>
+          <a:chOff x="0" y="0"/>
+          <a:chExt cx="0" cy="0"/>
+        </a:xfrm>
+      </p:grpSpPr>
+      <p:grpSp>
+        <p:nvGrpSpPr>
+          <p:cNvPr id="122" name="Group 121">
+            <a:extLst>
+              <a:ext uri="{FF2B5EF4-FFF2-40B4-BE49-F238E27FC236}">
+                <a16:creationId xmlns:a16="http://schemas.microsoft.com/office/drawing/2014/main" id="{403F4BD4-ECE4-484E-83B0-DE81C525BC35}"/>
+              </a:ext>
+            </a:extLst>
+          </p:cNvPr>
+          <p:cNvGrpSpPr/>
+          <p:nvPr/>
+        </p:nvGrpSpPr>
+        <p:grpSpPr>
+          <a:xfrm>
+            <a:off x="1148138" y="270724"/>
+            <a:ext cx="6244896" cy="5079887"/>
+            <a:chOff x="1148138" y="270724"/>
+            <a:chExt cx="6244896" cy="5079887"/>
+          </a:xfrm>
+        </p:grpSpPr>
+        <p:sp>
+          <p:nvSpPr>
+            <p:cNvPr id="9" name="Flowchart: Decision 8">
+              <a:extLst>
+                <a:ext uri="{FF2B5EF4-FFF2-40B4-BE49-F238E27FC236}">
+                  <a16:creationId xmlns:a16="http://schemas.microsoft.com/office/drawing/2014/main" id="{9BAB24E8-6FA0-8716-84A0-D2CA1E975C22}"/>
+                </a:ext>
+              </a:extLst>
+            </p:cNvPr>
+            <p:cNvSpPr/>
+            <p:nvPr/>
+          </p:nvSpPr>
+          <p:spPr>
+            <a:xfrm>
+              <a:off x="1148138" y="2821464"/>
+              <a:ext cx="1509883" cy="904637"/>
+            </a:xfrm>
+            <a:prstGeom prst="flowChartDecision">
+              <a:avLst/>
+            </a:prstGeom>
+          </p:spPr>
+          <p:style>
+            <a:lnRef idx="2">
+              <a:schemeClr val="dk1"/>
+            </a:lnRef>
+            <a:fillRef idx="1">
+              <a:schemeClr val="lt1"/>
+            </a:fillRef>
+            <a:effectRef idx="0">
+              <a:schemeClr val="dk1"/>
+            </a:effectRef>
+            <a:fontRef idx="minor">
+              <a:schemeClr val="dk1"/>
+            </a:fontRef>
+          </p:style>
+          <p:txBody>
+            <a:bodyPr rtlCol="0" anchor="ctr"/>
+            <a:lstStyle/>
+            <a:p>
+              <a:pPr algn="ctr"/>
+              <a:r>
+                <a:rPr lang="en-GB" sz="1200" dirty="0">
+                  <a:latin typeface="Lato Light" panose="020F0502020204030203" pitchFamily="34" charset="0"/>
+                  <a:ea typeface="Lato Light" panose="020F0502020204030203" pitchFamily="34" charset="0"/>
+                  <a:cs typeface="Lato Light" panose="020F0502020204030203" pitchFamily="34" charset="0"/>
+                </a:rPr>
+                <a:t>Scenario</a:t>
+              </a:r>
+            </a:p>
+          </p:txBody>
+        </p:sp>
+        <p:grpSp>
+          <p:nvGrpSpPr>
+            <p:cNvPr id="96" name="Group 95">
+              <a:extLst>
+                <a:ext uri="{FF2B5EF4-FFF2-40B4-BE49-F238E27FC236}">
+                  <a16:creationId xmlns:a16="http://schemas.microsoft.com/office/drawing/2014/main" id="{907E1DD8-E4D3-2B12-9E2E-45DA24D837D8}"/>
+                </a:ext>
+              </a:extLst>
+            </p:cNvPr>
+            <p:cNvGrpSpPr/>
+            <p:nvPr/>
+          </p:nvGrpSpPr>
+          <p:grpSpPr>
+            <a:xfrm>
+              <a:off x="1364174" y="270724"/>
+              <a:ext cx="6028860" cy="5079887"/>
+              <a:chOff x="1029877" y="339550"/>
+              <a:chExt cx="6028860" cy="5079887"/>
+            </a:xfrm>
+          </p:grpSpPr>
+          <p:sp>
+            <p:nvSpPr>
+              <p:cNvPr id="6" name="Flowchart: Multidocument 5">
+                <a:extLst>
+                  <a:ext uri="{FF2B5EF4-FFF2-40B4-BE49-F238E27FC236}">
+                    <a16:creationId xmlns:a16="http://schemas.microsoft.com/office/drawing/2014/main" id="{0E895BA0-D204-070C-2B77-1F2CF269C63B}"/>
+                  </a:ext>
+                </a:extLst>
+              </p:cNvPr>
+              <p:cNvSpPr/>
+              <p:nvPr/>
+            </p:nvSpPr>
+            <p:spPr>
+              <a:xfrm>
+                <a:off x="1029877" y="2024586"/>
+                <a:ext cx="1232919" cy="649649"/>
+              </a:xfrm>
+              <a:prstGeom prst="flowChartMultidocument">
+                <a:avLst/>
+              </a:prstGeom>
+              <a:ln>
+                <a:solidFill>
+                  <a:schemeClr val="tx1">
+                    <a:lumMod val="75000"/>
+                    <a:lumOff val="25000"/>
+                  </a:schemeClr>
+                </a:solidFill>
+              </a:ln>
+            </p:spPr>
+            <p:style>
+              <a:lnRef idx="2">
+                <a:schemeClr val="dk1"/>
+              </a:lnRef>
+              <a:fillRef idx="1">
+                <a:schemeClr val="lt1"/>
+              </a:fillRef>
+              <a:effectRef idx="0">
+                <a:schemeClr val="dk1"/>
+              </a:effectRef>
+              <a:fontRef idx="minor">
+                <a:schemeClr val="dk1"/>
+              </a:fontRef>
+            </p:style>
+            <p:txBody>
+              <a:bodyPr rtlCol="0" anchor="ctr"/>
+              <a:lstStyle/>
+              <a:p>
+                <a:pPr algn="ctr"/>
+                <a:r>
+                  <a:rPr lang="en-GB" sz="1200" dirty="0">
+                    <a:latin typeface="Lato Light" panose="020F0502020204030203" pitchFamily="34" charset="0"/>
+                    <a:ea typeface="Lato Light" panose="020F0502020204030203" pitchFamily="34" charset="0"/>
+                    <a:cs typeface="Lato Light" panose="020F0502020204030203" pitchFamily="34" charset="0"/>
+                  </a:rPr>
+                  <a:t>Dynamic predictors</a:t>
+                </a:r>
+              </a:p>
+            </p:txBody>
+          </p:sp>
+          <p:sp>
+            <p:nvSpPr>
+              <p:cNvPr id="7" name="Flowchart: Multidocument 6">
+                <a:extLst>
+                  <a:ext uri="{FF2B5EF4-FFF2-40B4-BE49-F238E27FC236}">
+                    <a16:creationId xmlns:a16="http://schemas.microsoft.com/office/drawing/2014/main" id="{2EBE057C-2BFB-1377-25EB-96C50F8E6696}"/>
+                  </a:ext>
+                </a:extLst>
+              </p:cNvPr>
+              <p:cNvSpPr/>
+              <p:nvPr/>
+            </p:nvSpPr>
+            <p:spPr>
+              <a:xfrm>
+                <a:off x="1079356" y="1181248"/>
+                <a:ext cx="1201971" cy="645345"/>
+              </a:xfrm>
+              <a:prstGeom prst="flowChartMultidocument">
+                <a:avLst/>
+              </a:prstGeom>
+              <a:ln>
+                <a:solidFill>
+                  <a:schemeClr val="tx1">
+                    <a:lumMod val="75000"/>
+                    <a:lumOff val="25000"/>
+                  </a:schemeClr>
+                </a:solidFill>
+              </a:ln>
+            </p:spPr>
+            <p:style>
+              <a:lnRef idx="2">
+                <a:schemeClr val="dk1"/>
+              </a:lnRef>
+              <a:fillRef idx="1">
+                <a:schemeClr val="lt1"/>
+              </a:fillRef>
+              <a:effectRef idx="0">
+                <a:schemeClr val="dk1"/>
+              </a:effectRef>
+              <a:fontRef idx="minor">
+                <a:schemeClr val="dk1"/>
+              </a:fontRef>
+            </p:style>
+            <p:txBody>
+              <a:bodyPr rtlCol="0" anchor="ctr"/>
+              <a:lstStyle/>
+              <a:p>
+                <a:pPr algn="ctr"/>
+                <a:r>
+                  <a:rPr lang="en-GB" sz="1200" dirty="0">
+                    <a:latin typeface="Lato Light" panose="020F0502020204030203" pitchFamily="34" charset="0"/>
+                    <a:ea typeface="Lato Light" panose="020F0502020204030203" pitchFamily="34" charset="0"/>
+                    <a:cs typeface="Lato Light" panose="020F0502020204030203" pitchFamily="34" charset="0"/>
+                  </a:rPr>
+                  <a:t>Static predictors</a:t>
+                </a:r>
+              </a:p>
+            </p:txBody>
+          </p:sp>
+          <p:sp>
+            <p:nvSpPr>
+              <p:cNvPr id="8" name="Flowchart: Multidocument 7">
+                <a:extLst>
+                  <a:ext uri="{FF2B5EF4-FFF2-40B4-BE49-F238E27FC236}">
+                    <a16:creationId xmlns:a16="http://schemas.microsoft.com/office/drawing/2014/main" id="{E62AA555-6398-B1C4-998C-DB2E396E34B2}"/>
+                  </a:ext>
+                </a:extLst>
+              </p:cNvPr>
+              <p:cNvSpPr/>
+              <p:nvPr/>
+            </p:nvSpPr>
+            <p:spPr>
+              <a:xfrm>
+                <a:off x="2646593" y="1239613"/>
+                <a:ext cx="1304027" cy="955394"/>
+              </a:xfrm>
+              <a:prstGeom prst="flowChartMultidocument">
+                <a:avLst/>
+              </a:prstGeom>
+              <a:ln>
+                <a:solidFill>
+                  <a:schemeClr val="tx1">
+                    <a:lumMod val="75000"/>
+                    <a:lumOff val="25000"/>
+                  </a:schemeClr>
+                </a:solidFill>
+              </a:ln>
+            </p:spPr>
+            <p:style>
+              <a:lnRef idx="2">
+                <a:schemeClr val="dk1"/>
+              </a:lnRef>
+              <a:fillRef idx="1">
+                <a:schemeClr val="lt1"/>
+              </a:fillRef>
+              <a:effectRef idx="0">
+                <a:schemeClr val="dk1"/>
+              </a:effectRef>
+              <a:fontRef idx="minor">
+                <a:schemeClr val="dk1"/>
+              </a:fontRef>
+            </p:style>
+            <p:txBody>
+              <a:bodyPr rtlCol="0" anchor="ctr"/>
+              <a:lstStyle/>
+              <a:p>
+                <a:pPr algn="ctr"/>
+                <a:r>
+                  <a:rPr lang="en-GB" sz="1200" dirty="0">
+                    <a:latin typeface="Lato Light" panose="020F0502020204030203" pitchFamily="34" charset="0"/>
+                    <a:ea typeface="Lato Light" panose="020F0502020204030203" pitchFamily="34" charset="0"/>
+                    <a:cs typeface="Lato Light" panose="020F0502020204030203" pitchFamily="34" charset="0"/>
+                  </a:rPr>
+                  <a:t>Transition potential models</a:t>
+                </a:r>
+              </a:p>
+            </p:txBody>
+          </p:sp>
+          <p:sp>
+            <p:nvSpPr>
+              <p:cNvPr id="10" name="Flowchart: Multidocument 9">
+                <a:extLst>
+                  <a:ext uri="{FF2B5EF4-FFF2-40B4-BE49-F238E27FC236}">
+                    <a16:creationId xmlns:a16="http://schemas.microsoft.com/office/drawing/2014/main" id="{47DE9C19-D4D8-EDF0-8DD4-DBB34D7140A4}"/>
+                  </a:ext>
+                </a:extLst>
+              </p:cNvPr>
+              <p:cNvSpPr/>
+              <p:nvPr/>
+            </p:nvSpPr>
+            <p:spPr>
+              <a:xfrm>
+                <a:off x="4252811" y="2588492"/>
+                <a:ext cx="1273424" cy="879437"/>
+              </a:xfrm>
+              <a:prstGeom prst="flowChartMultidocument">
+                <a:avLst/>
+              </a:prstGeom>
+              <a:ln>
+                <a:solidFill>
+                  <a:schemeClr val="tx1">
+                    <a:lumMod val="75000"/>
+                    <a:lumOff val="25000"/>
+                  </a:schemeClr>
+                </a:solidFill>
+              </a:ln>
+            </p:spPr>
+            <p:style>
+              <a:lnRef idx="2">
+                <a:schemeClr val="dk1"/>
+              </a:lnRef>
+              <a:fillRef idx="1">
+                <a:schemeClr val="lt1"/>
+              </a:fillRef>
+              <a:effectRef idx="0">
+                <a:schemeClr val="dk1"/>
+              </a:effectRef>
+              <a:fontRef idx="minor">
+                <a:schemeClr val="dk1"/>
+              </a:fontRef>
+            </p:style>
+            <p:txBody>
+              <a:bodyPr rtlCol="0" anchor="ctr"/>
+              <a:lstStyle/>
+              <a:p>
+                <a:pPr algn="ctr"/>
+                <a:r>
+                  <a:rPr lang="en-GB" sz="1200" dirty="0">
+                    <a:latin typeface="Lato Light" panose="020F0502020204030203" pitchFamily="34" charset="0"/>
+                    <a:ea typeface="Lato Light" panose="020F0502020204030203" pitchFamily="34" charset="0"/>
+                    <a:cs typeface="Lato Light" panose="020F0502020204030203" pitchFamily="34" charset="0"/>
+                  </a:rPr>
+                  <a:t>Transition potential maps</a:t>
+                </a:r>
+              </a:p>
+            </p:txBody>
+          </p:sp>
+          <p:sp>
+            <p:nvSpPr>
+              <p:cNvPr id="11" name="Flowchart: Document 10">
+                <a:extLst>
+                  <a:ext uri="{FF2B5EF4-FFF2-40B4-BE49-F238E27FC236}">
+                    <a16:creationId xmlns:a16="http://schemas.microsoft.com/office/drawing/2014/main" id="{E96C7314-A7AA-2970-3AA8-A374D83270E0}"/>
+                  </a:ext>
+                </a:extLst>
+              </p:cNvPr>
+              <p:cNvSpPr/>
+              <p:nvPr/>
+            </p:nvSpPr>
+            <p:spPr>
+              <a:xfrm>
+                <a:off x="4275172" y="4720212"/>
+                <a:ext cx="1058950" cy="699225"/>
+              </a:xfrm>
+              <a:prstGeom prst="flowChartDocument">
+                <a:avLst/>
+              </a:prstGeom>
+            </p:spPr>
+            <p:style>
+              <a:lnRef idx="2">
+                <a:schemeClr val="dk1"/>
+              </a:lnRef>
+              <a:fillRef idx="1">
+                <a:schemeClr val="lt1"/>
+              </a:fillRef>
+              <a:effectRef idx="0">
+                <a:schemeClr val="dk1"/>
+              </a:effectRef>
+              <a:fontRef idx="minor">
+                <a:schemeClr val="dk1"/>
+              </a:fontRef>
+            </p:style>
+            <p:txBody>
+              <a:bodyPr rtlCol="0" anchor="ctr"/>
+              <a:lstStyle/>
+              <a:p>
+                <a:pPr algn="ctr"/>
+                <a:r>
+                  <a:rPr lang="en-GB" sz="1200" dirty="0">
+                    <a:latin typeface="Lato Light" panose="020F0502020204030203" pitchFamily="34" charset="0"/>
+                    <a:ea typeface="Lato Light" panose="020F0502020204030203" pitchFamily="34" charset="0"/>
+                    <a:cs typeface="Lato Light" panose="020F0502020204030203" pitchFamily="34" charset="0"/>
+                  </a:rPr>
+                  <a:t>Simulated LULC (</a:t>
+                </a:r>
+                <a:r>
+                  <a:rPr lang="en-GB" sz="1200" dirty="0" err="1">
+                    <a:latin typeface="Lato Light" panose="020F0502020204030203" pitchFamily="34" charset="0"/>
+                    <a:ea typeface="Lato Light" panose="020F0502020204030203" pitchFamily="34" charset="0"/>
+                    <a:cs typeface="Lato Light" panose="020F0502020204030203" pitchFamily="34" charset="0"/>
+                  </a:rPr>
+                  <a:t>t+x</a:t>
+                </a:r>
+                <a:r>
+                  <a:rPr lang="en-GB" sz="1517" dirty="0">
+                    <a:latin typeface="Lato Light" panose="020F0502020204030203" pitchFamily="34" charset="0"/>
+                    <a:ea typeface="Lato Light" panose="020F0502020204030203" pitchFamily="34" charset="0"/>
+                    <a:cs typeface="Lato Light" panose="020F0502020204030203" pitchFamily="34" charset="0"/>
+                  </a:rPr>
+                  <a:t>)</a:t>
+                </a:r>
+              </a:p>
+            </p:txBody>
+          </p:sp>
+          <p:sp>
+            <p:nvSpPr>
+              <p:cNvPr id="12" name="Flowchart: Document 11">
+                <a:extLst>
+                  <a:ext uri="{FF2B5EF4-FFF2-40B4-BE49-F238E27FC236}">
+                    <a16:creationId xmlns:a16="http://schemas.microsoft.com/office/drawing/2014/main" id="{A2525305-0B05-74CE-2861-D9F0F46F38F9}"/>
+                  </a:ext>
+                </a:extLst>
+              </p:cNvPr>
+              <p:cNvSpPr/>
+              <p:nvPr/>
+            </p:nvSpPr>
+            <p:spPr>
+              <a:xfrm>
+                <a:off x="4256487" y="339550"/>
+                <a:ext cx="1201970" cy="648857"/>
+              </a:xfrm>
+              <a:prstGeom prst="flowChartDocument">
+                <a:avLst/>
+              </a:prstGeom>
+            </p:spPr>
+            <p:style>
+              <a:lnRef idx="2">
+                <a:schemeClr val="dk1"/>
+              </a:lnRef>
+              <a:fillRef idx="1">
+                <a:schemeClr val="lt1"/>
+              </a:fillRef>
+              <a:effectRef idx="0">
+                <a:schemeClr val="dk1"/>
+              </a:effectRef>
+              <a:fontRef idx="minor">
+                <a:schemeClr val="dk1"/>
+              </a:fontRef>
+            </p:style>
+            <p:txBody>
+              <a:bodyPr rtlCol="0" anchor="ctr"/>
+              <a:lstStyle/>
+              <a:p>
+                <a:pPr algn="ctr"/>
+                <a:r>
+                  <a:rPr lang="en-GB" sz="1200" dirty="0">
+                    <a:latin typeface="Lato Light" panose="020F0502020204030203" pitchFamily="34" charset="0"/>
+                    <a:ea typeface="Lato Light" panose="020F0502020204030203" pitchFamily="34" charset="0"/>
+                    <a:cs typeface="Lato Light" panose="020F0502020204030203" pitchFamily="34" charset="0"/>
+                  </a:rPr>
+                  <a:t> LULC (t)</a:t>
+                </a:r>
+              </a:p>
+            </p:txBody>
+          </p:sp>
+          <p:sp>
+            <p:nvSpPr>
+              <p:cNvPr id="13" name="Flowchart: Process 12">
+                <a:extLst>
+                  <a:ext uri="{FF2B5EF4-FFF2-40B4-BE49-F238E27FC236}">
+                    <a16:creationId xmlns:a16="http://schemas.microsoft.com/office/drawing/2014/main" id="{35844639-55C4-6A44-6938-188C13D58C8E}"/>
+                  </a:ext>
+                </a:extLst>
+              </p:cNvPr>
+              <p:cNvSpPr/>
+              <p:nvPr/>
+            </p:nvSpPr>
+            <p:spPr>
+              <a:xfrm>
+                <a:off x="4224636" y="3751684"/>
+                <a:ext cx="1177911" cy="612648"/>
+              </a:xfrm>
+              <a:prstGeom prst="flowChartProcess">
+                <a:avLst/>
+              </a:prstGeom>
+              <a:solidFill>
+                <a:schemeClr val="bg1"/>
+              </a:solidFill>
+              <a:ln>
+                <a:solidFill>
+                  <a:schemeClr val="tx1">
+                    <a:lumMod val="85000"/>
+                    <a:lumOff val="15000"/>
+                  </a:schemeClr>
+                </a:solidFill>
+              </a:ln>
+            </p:spPr>
+            <p:style>
+              <a:lnRef idx="2">
+                <a:schemeClr val="accent1">
+                  <a:shade val="50000"/>
+                </a:schemeClr>
+              </a:lnRef>
+              <a:fillRef idx="1">
+                <a:schemeClr val="accent1"/>
+              </a:fillRef>
+              <a:effectRef idx="0">
+                <a:schemeClr val="accent1"/>
+              </a:effectRef>
+              <a:fontRef idx="minor">
+                <a:schemeClr val="lt1"/>
+              </a:fontRef>
+            </p:style>
+            <p:txBody>
+              <a:bodyPr rtlCol="0" anchor="ctr"/>
+              <a:lstStyle/>
+              <a:p>
+                <a:pPr algn="ctr"/>
+                <a:r>
+                  <a:rPr lang="en-GB" sz="1200" dirty="0">
+                    <a:solidFill>
+                      <a:schemeClr val="tx1"/>
+                    </a:solidFill>
+                    <a:latin typeface="Lato Light" panose="020F0502020204030203" pitchFamily="34" charset="0"/>
+                    <a:ea typeface="Lato Light" panose="020F0502020204030203" pitchFamily="34" charset="0"/>
+                    <a:cs typeface="Lato Light" panose="020F0502020204030203" pitchFamily="34" charset="0"/>
+                  </a:rPr>
+                  <a:t>Transition</a:t>
+                </a:r>
+              </a:p>
+              <a:p>
+                <a:pPr algn="ctr"/>
+                <a:r>
+                  <a:rPr lang="en-GB" sz="1200" dirty="0">
+                    <a:solidFill>
+                      <a:schemeClr val="tx1"/>
+                    </a:solidFill>
+                    <a:latin typeface="Lato Light" panose="020F0502020204030203" pitchFamily="34" charset="0"/>
+                    <a:ea typeface="Lato Light" panose="020F0502020204030203" pitchFamily="34" charset="0"/>
+                    <a:cs typeface="Lato Light" panose="020F0502020204030203" pitchFamily="34" charset="0"/>
+                  </a:rPr>
+                  <a:t>allocation</a:t>
+                </a:r>
+              </a:p>
+            </p:txBody>
+          </p:sp>
+          <p:sp>
+            <p:nvSpPr>
+              <p:cNvPr id="14" name="Flowchart: Process 13">
+                <a:extLst>
+                  <a:ext uri="{FF2B5EF4-FFF2-40B4-BE49-F238E27FC236}">
+                    <a16:creationId xmlns:a16="http://schemas.microsoft.com/office/drawing/2014/main" id="{30EC2951-1D3C-ED1E-6869-C0A6A3D50711}"/>
+                  </a:ext>
+                </a:extLst>
+              </p:cNvPr>
+              <p:cNvSpPr/>
+              <p:nvPr/>
+            </p:nvSpPr>
+            <p:spPr>
+              <a:xfrm>
+                <a:off x="4256487" y="1230122"/>
+                <a:ext cx="1201970" cy="879436"/>
+              </a:xfrm>
+              <a:prstGeom prst="flowChartProcess">
+                <a:avLst/>
+              </a:prstGeom>
+              <a:solidFill>
+                <a:schemeClr val="bg1"/>
+              </a:solidFill>
+              <a:ln>
+                <a:solidFill>
+                  <a:schemeClr val="tx1"/>
+                </a:solidFill>
+              </a:ln>
+            </p:spPr>
+            <p:style>
+              <a:lnRef idx="2">
+                <a:schemeClr val="accent1">
+                  <a:shade val="50000"/>
+                </a:schemeClr>
+              </a:lnRef>
+              <a:fillRef idx="1">
+                <a:schemeClr val="accent1"/>
+              </a:fillRef>
+              <a:effectRef idx="0">
+                <a:schemeClr val="accent1"/>
+              </a:effectRef>
+              <a:fontRef idx="minor">
+                <a:schemeClr val="lt1"/>
+              </a:fontRef>
+            </p:style>
+            <p:txBody>
+              <a:bodyPr rtlCol="0" anchor="ctr"/>
+              <a:lstStyle/>
+              <a:p>
+                <a:pPr algn="ctr"/>
+                <a:r>
+                  <a:rPr lang="en-GB" sz="1200" dirty="0">
+                    <a:solidFill>
+                      <a:schemeClr val="tx1"/>
+                    </a:solidFill>
+                    <a:latin typeface="Lato Light" panose="020F0502020204030203" pitchFamily="34" charset="0"/>
+                    <a:ea typeface="Lato Light" panose="020F0502020204030203" pitchFamily="34" charset="0"/>
+                    <a:cs typeface="Lato Light" panose="020F0502020204030203" pitchFamily="34" charset="0"/>
+                  </a:rPr>
+                  <a:t>Cellular Transition potential prediction</a:t>
+                </a:r>
+              </a:p>
+            </p:txBody>
+          </p:sp>
+          <p:sp>
+            <p:nvSpPr>
+              <p:cNvPr id="15" name="Flowchart: Alternate Process 14">
+                <a:extLst>
+                  <a:ext uri="{FF2B5EF4-FFF2-40B4-BE49-F238E27FC236}">
+                    <a16:creationId xmlns:a16="http://schemas.microsoft.com/office/drawing/2014/main" id="{D6D59A8C-DFF7-52B1-E8D4-6A258E33F0FD}"/>
+                  </a:ext>
+                </a:extLst>
+              </p:cNvPr>
+              <p:cNvSpPr/>
+              <p:nvPr/>
+            </p:nvSpPr>
+            <p:spPr>
+              <a:xfrm>
+                <a:off x="2641344" y="2575893"/>
+                <a:ext cx="1232919" cy="904637"/>
+              </a:xfrm>
+              <a:prstGeom prst="flowChartAlternateProcess">
+                <a:avLst/>
+              </a:prstGeom>
+              <a:solidFill>
+                <a:schemeClr val="bg1"/>
+              </a:solidFill>
+              <a:ln>
+                <a:solidFill>
+                  <a:schemeClr val="tx1"/>
+                </a:solidFill>
+              </a:ln>
+            </p:spPr>
+            <p:style>
+              <a:lnRef idx="2">
+                <a:schemeClr val="accent1">
+                  <a:shade val="50000"/>
+                </a:schemeClr>
+              </a:lnRef>
+              <a:fillRef idx="1">
+                <a:schemeClr val="accent1"/>
+              </a:fillRef>
+              <a:effectRef idx="0">
+                <a:schemeClr val="accent1"/>
+              </a:effectRef>
+              <a:fontRef idx="minor">
+                <a:schemeClr val="lt1"/>
+              </a:fontRef>
+            </p:style>
+            <p:txBody>
+              <a:bodyPr rtlCol="0" anchor="ctr"/>
+              <a:lstStyle/>
+              <a:p>
+                <a:pPr algn="ctr"/>
+                <a:r>
+                  <a:rPr lang="en-GB" sz="1200" dirty="0">
+                    <a:solidFill>
+                      <a:schemeClr val="tx1"/>
+                    </a:solidFill>
+                    <a:latin typeface="Lato Light" panose="020F0502020204030203" pitchFamily="34" charset="0"/>
+                    <a:ea typeface="Lato Light" panose="020F0502020204030203" pitchFamily="34" charset="0"/>
+                    <a:cs typeface="Lato Light" panose="020F0502020204030203" pitchFamily="34" charset="0"/>
+                  </a:rPr>
+                  <a:t>Transition potential perturbation</a:t>
+                </a:r>
+              </a:p>
+            </p:txBody>
+          </p:sp>
+          <p:sp>
+            <p:nvSpPr>
+              <p:cNvPr id="16" name="Flowchart: Alternate Process 15">
+                <a:extLst>
+                  <a:ext uri="{FF2B5EF4-FFF2-40B4-BE49-F238E27FC236}">
+                    <a16:creationId xmlns:a16="http://schemas.microsoft.com/office/drawing/2014/main" id="{C9FB045D-1484-809E-7CC2-A96640575CCE}"/>
+                  </a:ext>
+                </a:extLst>
+              </p:cNvPr>
+              <p:cNvSpPr/>
+              <p:nvPr/>
+            </p:nvSpPr>
+            <p:spPr>
+              <a:xfrm>
+                <a:off x="2634017" y="3707013"/>
+                <a:ext cx="1207204" cy="904637"/>
+              </a:xfrm>
+              <a:prstGeom prst="flowChartAlternateProcess">
+                <a:avLst/>
+              </a:prstGeom>
+              <a:solidFill>
+                <a:schemeClr val="bg1"/>
+              </a:solidFill>
+              <a:ln>
+                <a:solidFill>
+                  <a:schemeClr val="tx1"/>
+                </a:solidFill>
+              </a:ln>
+            </p:spPr>
+            <p:style>
+              <a:lnRef idx="2">
+                <a:schemeClr val="accent1">
+                  <a:shade val="50000"/>
+                </a:schemeClr>
+              </a:lnRef>
+              <a:fillRef idx="1">
+                <a:schemeClr val="accent1"/>
+              </a:fillRef>
+              <a:effectRef idx="0">
+                <a:schemeClr val="accent1"/>
+              </a:effectRef>
+              <a:fontRef idx="minor">
+                <a:schemeClr val="lt1"/>
+              </a:fontRef>
+            </p:style>
+            <p:txBody>
+              <a:bodyPr rtlCol="0" anchor="ctr"/>
+              <a:lstStyle/>
+              <a:p>
+                <a:pPr algn="ctr"/>
+                <a:r>
+                  <a:rPr lang="en-GB" sz="1200" dirty="0">
+                    <a:solidFill>
+                      <a:schemeClr val="tx1"/>
+                    </a:solidFill>
+                    <a:latin typeface="Lato Light" panose="020F0502020204030203" pitchFamily="34" charset="0"/>
+                    <a:ea typeface="Lato Light" panose="020F0502020204030203" pitchFamily="34" charset="0"/>
+                    <a:cs typeface="Lato Light" panose="020F0502020204030203" pitchFamily="34" charset="0"/>
+                  </a:rPr>
+                  <a:t>Transition occurrence rates</a:t>
+                </a:r>
+              </a:p>
+            </p:txBody>
+          </p:sp>
+          <p:cxnSp>
+            <p:nvCxnSpPr>
+              <p:cNvPr id="18" name="Straight Arrow Connector 17">
+                <a:extLst>
+                  <a:ext uri="{FF2B5EF4-FFF2-40B4-BE49-F238E27FC236}">
+                    <a16:creationId xmlns:a16="http://schemas.microsoft.com/office/drawing/2014/main" id="{930567D9-F389-1AC3-2A66-929493944685}"/>
+                  </a:ext>
+                </a:extLst>
+              </p:cNvPr>
+              <p:cNvCxnSpPr>
+                <a:cxnSpLocks/>
+                <a:stCxn id="9" idx="0"/>
+                <a:endCxn id="111" idx="2"/>
+              </p:cNvCxnSpPr>
+              <p:nvPr/>
+            </p:nvCxnSpPr>
+            <p:spPr>
+              <a:xfrm flipH="1" flipV="1">
+                <a:off x="1568552" y="2655032"/>
+                <a:ext cx="231" cy="235258"/>
+              </a:xfrm>
+              <a:prstGeom prst="straightConnector1">
+                <a:avLst/>
+              </a:prstGeom>
+              <a:ln>
+                <a:solidFill>
+                  <a:schemeClr val="tx1">
+                    <a:lumMod val="85000"/>
+                    <a:lumOff val="15000"/>
+                  </a:schemeClr>
+                </a:solidFill>
+                <a:tailEnd type="triangle"/>
+              </a:ln>
+            </p:spPr>
+            <p:style>
+              <a:lnRef idx="1">
+                <a:schemeClr val="accent1"/>
+              </a:lnRef>
+              <a:fillRef idx="0">
+                <a:schemeClr val="accent1"/>
+              </a:fillRef>
+              <a:effectRef idx="0">
+                <a:schemeClr val="accent1"/>
+              </a:effectRef>
+              <a:fontRef idx="minor">
+                <a:schemeClr val="tx1"/>
+              </a:fontRef>
+            </p:style>
+          </p:cxnSp>
+          <p:cxnSp>
+            <p:nvCxnSpPr>
+              <p:cNvPr id="21" name="Straight Arrow Connector 20">
+                <a:extLst>
+                  <a:ext uri="{FF2B5EF4-FFF2-40B4-BE49-F238E27FC236}">
+                    <a16:creationId xmlns:a16="http://schemas.microsoft.com/office/drawing/2014/main" id="{C4284097-C141-3E23-D173-5C55046B4E81}"/>
+                  </a:ext>
+                </a:extLst>
+              </p:cNvPr>
+              <p:cNvCxnSpPr>
+                <a:cxnSpLocks/>
+                <a:stCxn id="12" idx="2"/>
+                <a:endCxn id="14" idx="0"/>
+              </p:cNvCxnSpPr>
+              <p:nvPr/>
+            </p:nvCxnSpPr>
+            <p:spPr>
+              <a:xfrm>
+                <a:off x="4857472" y="945510"/>
+                <a:ext cx="0" cy="284612"/>
+              </a:xfrm>
+              <a:prstGeom prst="straightConnector1">
+                <a:avLst/>
+              </a:prstGeom>
+              <a:ln>
+                <a:solidFill>
+                  <a:schemeClr val="tx1">
+                    <a:lumMod val="85000"/>
+                    <a:lumOff val="15000"/>
+                  </a:schemeClr>
+                </a:solidFill>
+                <a:tailEnd type="triangle"/>
+              </a:ln>
+            </p:spPr>
+            <p:style>
+              <a:lnRef idx="1">
+                <a:schemeClr val="accent1"/>
+              </a:lnRef>
+              <a:fillRef idx="0">
+                <a:schemeClr val="accent1"/>
+              </a:fillRef>
+              <a:effectRef idx="0">
+                <a:schemeClr val="accent1"/>
+              </a:effectRef>
+              <a:fontRef idx="minor">
+                <a:schemeClr val="tx1"/>
+              </a:fontRef>
+            </p:style>
+          </p:cxnSp>
+          <p:cxnSp>
+            <p:nvCxnSpPr>
+              <p:cNvPr id="35" name="Connector: Elbow 34">
+                <a:extLst>
+                  <a:ext uri="{FF2B5EF4-FFF2-40B4-BE49-F238E27FC236}">
+                    <a16:creationId xmlns:a16="http://schemas.microsoft.com/office/drawing/2014/main" id="{9777F8F5-C9B1-EFC6-F910-AFB3D766CEF5}"/>
+                  </a:ext>
+                </a:extLst>
+              </p:cNvPr>
+              <p:cNvCxnSpPr>
+                <a:cxnSpLocks/>
+                <a:stCxn id="9" idx="2"/>
+                <a:endCxn id="16" idx="1"/>
+              </p:cNvCxnSpPr>
+              <p:nvPr/>
+            </p:nvCxnSpPr>
+            <p:spPr>
+              <a:xfrm rot="16200000" flipH="1">
+                <a:off x="1919198" y="3444512"/>
+                <a:ext cx="364405" cy="1065234"/>
+              </a:xfrm>
+              <a:prstGeom prst="bentConnector2">
+                <a:avLst/>
+              </a:prstGeom>
+              <a:ln>
+                <a:solidFill>
+                  <a:schemeClr val="tx1">
+                    <a:lumMod val="85000"/>
+                    <a:lumOff val="15000"/>
+                  </a:schemeClr>
+                </a:solidFill>
+                <a:tailEnd type="triangle"/>
+              </a:ln>
+            </p:spPr>
+            <p:style>
+              <a:lnRef idx="1">
+                <a:schemeClr val="accent1"/>
+              </a:lnRef>
+              <a:fillRef idx="0">
+                <a:schemeClr val="accent1"/>
+              </a:fillRef>
+              <a:effectRef idx="0">
+                <a:schemeClr val="accent1"/>
+              </a:effectRef>
+              <a:fontRef idx="minor">
+                <a:schemeClr val="tx1"/>
+              </a:fontRef>
+            </p:style>
+          </p:cxnSp>
+          <p:cxnSp>
+            <p:nvCxnSpPr>
+              <p:cNvPr id="42" name="Straight Arrow Connector 41">
+                <a:extLst>
+                  <a:ext uri="{FF2B5EF4-FFF2-40B4-BE49-F238E27FC236}">
+                    <a16:creationId xmlns:a16="http://schemas.microsoft.com/office/drawing/2014/main" id="{E681C5EB-A555-A3AF-2859-53913EEF7EEC}"/>
+                  </a:ext>
+                </a:extLst>
+              </p:cNvPr>
+              <p:cNvCxnSpPr>
+                <a:cxnSpLocks/>
+                <a:stCxn id="15" idx="3"/>
+                <a:endCxn id="10" idx="1"/>
+              </p:cNvCxnSpPr>
+              <p:nvPr/>
+            </p:nvCxnSpPr>
+            <p:spPr>
+              <a:xfrm flipV="1">
+                <a:off x="3874263" y="3028211"/>
+                <a:ext cx="378548" cy="1"/>
+              </a:xfrm>
+              <a:prstGeom prst="straightConnector1">
+                <a:avLst/>
+              </a:prstGeom>
+              <a:ln>
+                <a:solidFill>
+                  <a:schemeClr val="tx1">
+                    <a:lumMod val="85000"/>
+                    <a:lumOff val="15000"/>
+                  </a:schemeClr>
+                </a:solidFill>
+                <a:tailEnd type="triangle"/>
+              </a:ln>
+            </p:spPr>
+            <p:style>
+              <a:lnRef idx="1">
+                <a:schemeClr val="accent1"/>
+              </a:lnRef>
+              <a:fillRef idx="0">
+                <a:schemeClr val="accent1"/>
+              </a:fillRef>
+              <a:effectRef idx="0">
+                <a:schemeClr val="accent1"/>
+              </a:effectRef>
+              <a:fontRef idx="minor">
+                <a:schemeClr val="tx1"/>
+              </a:fontRef>
+            </p:style>
+          </p:cxnSp>
+          <p:cxnSp>
+            <p:nvCxnSpPr>
+              <p:cNvPr id="45" name="Straight Arrow Connector 44">
+                <a:extLst>
+                  <a:ext uri="{FF2B5EF4-FFF2-40B4-BE49-F238E27FC236}">
+                    <a16:creationId xmlns:a16="http://schemas.microsoft.com/office/drawing/2014/main" id="{83D955EA-2DB1-8969-2627-ED17E3879356}"/>
+                  </a:ext>
+                </a:extLst>
+              </p:cNvPr>
+              <p:cNvCxnSpPr>
+                <a:cxnSpLocks/>
+                <a:endCxn id="13" idx="1"/>
+              </p:cNvCxnSpPr>
+              <p:nvPr/>
+            </p:nvCxnSpPr>
+            <p:spPr>
+              <a:xfrm>
+                <a:off x="3879511" y="4058008"/>
+                <a:ext cx="345125" cy="0"/>
+              </a:xfrm>
+              <a:prstGeom prst="straightConnector1">
+                <a:avLst/>
+              </a:prstGeom>
+              <a:ln>
+                <a:solidFill>
+                  <a:schemeClr val="tx1">
+                    <a:lumMod val="85000"/>
+                    <a:lumOff val="15000"/>
+                  </a:schemeClr>
+                </a:solidFill>
+                <a:tailEnd type="triangle"/>
+              </a:ln>
+            </p:spPr>
+            <p:style>
+              <a:lnRef idx="1">
+                <a:schemeClr val="accent1"/>
+              </a:lnRef>
+              <a:fillRef idx="0">
+                <a:schemeClr val="accent1"/>
+              </a:fillRef>
+              <a:effectRef idx="0">
+                <a:schemeClr val="accent1"/>
+              </a:effectRef>
+              <a:fontRef idx="minor">
+                <a:schemeClr val="tx1"/>
+              </a:fontRef>
+            </p:style>
+          </p:cxnSp>
+          <p:cxnSp>
+            <p:nvCxnSpPr>
+              <p:cNvPr id="67" name="Straight Arrow Connector 66">
+                <a:extLst>
+                  <a:ext uri="{FF2B5EF4-FFF2-40B4-BE49-F238E27FC236}">
+                    <a16:creationId xmlns:a16="http://schemas.microsoft.com/office/drawing/2014/main" id="{19FBC0E7-49AD-B21C-82C4-4BD91F9C43B8}"/>
+                  </a:ext>
+                </a:extLst>
+              </p:cNvPr>
+              <p:cNvCxnSpPr>
+                <a:cxnSpLocks/>
+                <a:stCxn id="10" idx="2"/>
+                <a:endCxn id="13" idx="0"/>
+              </p:cNvCxnSpPr>
+              <p:nvPr/>
+            </p:nvCxnSpPr>
+            <p:spPr>
+              <a:xfrm>
+                <a:off x="4800973" y="3434624"/>
+                <a:ext cx="12619" cy="317060"/>
+              </a:xfrm>
+              <a:prstGeom prst="straightConnector1">
+                <a:avLst/>
+              </a:prstGeom>
+              <a:ln>
+                <a:solidFill>
+                  <a:schemeClr val="tx1">
+                    <a:lumMod val="85000"/>
+                    <a:lumOff val="15000"/>
+                  </a:schemeClr>
+                </a:solidFill>
+                <a:tailEnd type="triangle"/>
+              </a:ln>
+            </p:spPr>
+            <p:style>
+              <a:lnRef idx="1">
+                <a:schemeClr val="accent1"/>
+              </a:lnRef>
+              <a:fillRef idx="0">
+                <a:schemeClr val="accent1"/>
+              </a:fillRef>
+              <a:effectRef idx="0">
+                <a:schemeClr val="accent1"/>
+              </a:effectRef>
+              <a:fontRef idx="minor">
+                <a:schemeClr val="tx1"/>
+              </a:fontRef>
+            </p:style>
+          </p:cxnSp>
+          <p:cxnSp>
+            <p:nvCxnSpPr>
+              <p:cNvPr id="76" name="Straight Arrow Connector 75">
+                <a:extLst>
+                  <a:ext uri="{FF2B5EF4-FFF2-40B4-BE49-F238E27FC236}">
+                    <a16:creationId xmlns:a16="http://schemas.microsoft.com/office/drawing/2014/main" id="{5562BAE5-044B-BC92-232A-E894ED2EA21F}"/>
+                  </a:ext>
+                </a:extLst>
+              </p:cNvPr>
+              <p:cNvCxnSpPr>
+                <a:cxnSpLocks/>
+                <a:stCxn id="14" idx="2"/>
+              </p:cNvCxnSpPr>
+              <p:nvPr/>
+            </p:nvCxnSpPr>
+            <p:spPr>
+              <a:xfrm>
+                <a:off x="4857472" y="2109558"/>
+                <a:ext cx="0" cy="496914"/>
+              </a:xfrm>
+              <a:prstGeom prst="straightConnector1">
+                <a:avLst/>
+              </a:prstGeom>
+              <a:ln>
+                <a:solidFill>
+                  <a:schemeClr val="tx1">
+                    <a:lumMod val="85000"/>
+                    <a:lumOff val="15000"/>
+                  </a:schemeClr>
+                </a:solidFill>
+                <a:tailEnd type="triangle"/>
+              </a:ln>
+            </p:spPr>
+            <p:style>
+              <a:lnRef idx="1">
+                <a:schemeClr val="accent1"/>
+              </a:lnRef>
+              <a:fillRef idx="0">
+                <a:schemeClr val="accent1"/>
+              </a:fillRef>
+              <a:effectRef idx="0">
+                <a:schemeClr val="accent1"/>
+              </a:effectRef>
+              <a:fontRef idx="minor">
+                <a:schemeClr val="tx1"/>
+              </a:fontRef>
+            </p:style>
+          </p:cxnSp>
+          <p:cxnSp>
+            <p:nvCxnSpPr>
+              <p:cNvPr id="79" name="Straight Arrow Connector 78">
+                <a:extLst>
+                  <a:ext uri="{FF2B5EF4-FFF2-40B4-BE49-F238E27FC236}">
+                    <a16:creationId xmlns:a16="http://schemas.microsoft.com/office/drawing/2014/main" id="{1EAB6A18-7E29-F4B8-738D-43339DFFA246}"/>
+                  </a:ext>
+                </a:extLst>
+              </p:cNvPr>
+              <p:cNvCxnSpPr>
+                <a:cxnSpLocks/>
+                <a:stCxn id="85" idx="1"/>
+                <a:endCxn id="13" idx="3"/>
+              </p:cNvCxnSpPr>
+              <p:nvPr/>
+            </p:nvCxnSpPr>
+            <p:spPr>
+              <a:xfrm flipH="1">
+                <a:off x="5402547" y="4058008"/>
+                <a:ext cx="352164" cy="0"/>
+              </a:xfrm>
+              <a:prstGeom prst="straightConnector1">
+                <a:avLst/>
+              </a:prstGeom>
+              <a:ln>
+                <a:solidFill>
+                  <a:schemeClr val="tx1">
+                    <a:lumMod val="85000"/>
+                    <a:lumOff val="15000"/>
+                  </a:schemeClr>
+                </a:solidFill>
+                <a:tailEnd type="triangle"/>
+              </a:ln>
+            </p:spPr>
+            <p:style>
+              <a:lnRef idx="1">
+                <a:schemeClr val="accent1"/>
+              </a:lnRef>
+              <a:fillRef idx="0">
+                <a:schemeClr val="accent1"/>
+              </a:fillRef>
+              <a:effectRef idx="0">
+                <a:schemeClr val="accent1"/>
+              </a:effectRef>
+              <a:fontRef idx="minor">
+                <a:schemeClr val="tx1"/>
+              </a:fontRef>
+            </p:style>
+          </p:cxnSp>
+          <p:sp>
+            <p:nvSpPr>
+              <p:cNvPr id="85" name="Flowchart: Document 84">
+                <a:extLst>
+                  <a:ext uri="{FF2B5EF4-FFF2-40B4-BE49-F238E27FC236}">
+                    <a16:creationId xmlns:a16="http://schemas.microsoft.com/office/drawing/2014/main" id="{7693D491-728F-C110-0C72-183A2513B8CC}"/>
+                  </a:ext>
+                </a:extLst>
+              </p:cNvPr>
+              <p:cNvSpPr/>
+              <p:nvPr/>
+            </p:nvSpPr>
+            <p:spPr>
+              <a:xfrm>
+                <a:off x="5754711" y="3761657"/>
+                <a:ext cx="1304026" cy="592702"/>
+              </a:xfrm>
+              <a:prstGeom prst="flowChartDocument">
+                <a:avLst/>
+              </a:prstGeom>
+            </p:spPr>
+            <p:style>
+              <a:lnRef idx="2">
+                <a:schemeClr val="dk1"/>
+              </a:lnRef>
+              <a:fillRef idx="1">
+                <a:schemeClr val="lt1"/>
+              </a:fillRef>
+              <a:effectRef idx="0">
+                <a:schemeClr val="dk1"/>
+              </a:effectRef>
+              <a:fontRef idx="minor">
+                <a:schemeClr val="dk1"/>
+              </a:fontRef>
+            </p:style>
+            <p:txBody>
+              <a:bodyPr rtlCol="0" anchor="ctr"/>
+              <a:lstStyle/>
+              <a:p>
+                <a:pPr algn="ctr"/>
+                <a:r>
+                  <a:rPr lang="en-GB" sz="1200" dirty="0">
+                    <a:latin typeface="Lato Light" panose="020F0502020204030203" pitchFamily="34" charset="0"/>
+                    <a:ea typeface="Lato Light" panose="020F0502020204030203" pitchFamily="34" charset="0"/>
+                    <a:cs typeface="Lato Light" panose="020F0502020204030203" pitchFamily="34" charset="0"/>
+                  </a:rPr>
+                  <a:t>Allocation</a:t>
+                </a:r>
+              </a:p>
+              <a:p>
+                <a:pPr algn="ctr"/>
+                <a:r>
+                  <a:rPr lang="en-GB" sz="1200" dirty="0">
+                    <a:latin typeface="Lato Light" panose="020F0502020204030203" pitchFamily="34" charset="0"/>
+                    <a:ea typeface="Lato Light" panose="020F0502020204030203" pitchFamily="34" charset="0"/>
+                    <a:cs typeface="Lato Light" panose="020F0502020204030203" pitchFamily="34" charset="0"/>
+                  </a:rPr>
+                  <a:t>parameters</a:t>
+                </a:r>
+              </a:p>
+            </p:txBody>
+          </p:sp>
+          <p:cxnSp>
+            <p:nvCxnSpPr>
+              <p:cNvPr id="92" name="Straight Arrow Connector 91">
+                <a:extLst>
+                  <a:ext uri="{FF2B5EF4-FFF2-40B4-BE49-F238E27FC236}">
+                    <a16:creationId xmlns:a16="http://schemas.microsoft.com/office/drawing/2014/main" id="{4655569D-FA15-9E7B-BEE9-0126D8DB8CB2}"/>
+                  </a:ext>
+                </a:extLst>
+              </p:cNvPr>
+              <p:cNvCxnSpPr>
+                <a:cxnSpLocks/>
+                <a:stCxn id="13" idx="2"/>
+                <a:endCxn id="11" idx="0"/>
+              </p:cNvCxnSpPr>
+              <p:nvPr/>
+            </p:nvCxnSpPr>
+            <p:spPr>
+              <a:xfrm flipH="1">
+                <a:off x="4804647" y="4364332"/>
+                <a:ext cx="8945" cy="355880"/>
+              </a:xfrm>
+              <a:prstGeom prst="straightConnector1">
+                <a:avLst/>
+              </a:prstGeom>
+              <a:ln>
+                <a:solidFill>
+                  <a:schemeClr val="tx1">
+                    <a:lumMod val="85000"/>
+                    <a:lumOff val="15000"/>
+                  </a:schemeClr>
+                </a:solidFill>
+                <a:tailEnd type="triangle"/>
+              </a:ln>
+            </p:spPr>
+            <p:style>
+              <a:lnRef idx="1">
+                <a:schemeClr val="accent1"/>
+              </a:lnRef>
+              <a:fillRef idx="0">
+                <a:schemeClr val="accent1"/>
+              </a:fillRef>
+              <a:effectRef idx="0">
+                <a:schemeClr val="accent1"/>
+              </a:effectRef>
+              <a:fontRef idx="minor">
+                <a:schemeClr val="tx1"/>
+              </a:fontRef>
+            </p:style>
+          </p:cxnSp>
+        </p:grpSp>
+        <p:cxnSp>
+          <p:nvCxnSpPr>
+            <p:cNvPr id="59" name="Straight Arrow Connector 58">
+              <a:extLst>
+                <a:ext uri="{FF2B5EF4-FFF2-40B4-BE49-F238E27FC236}">
+                  <a16:creationId xmlns:a16="http://schemas.microsoft.com/office/drawing/2014/main" id="{85E064B7-1CEF-4F9E-9F17-B8AC0C7EE38E}"/>
+                </a:ext>
+              </a:extLst>
+            </p:cNvPr>
+            <p:cNvCxnSpPr>
+              <a:cxnSpLocks/>
+            </p:cNvCxnSpPr>
+            <p:nvPr/>
+          </p:nvCxnSpPr>
+          <p:spPr>
+            <a:xfrm>
+              <a:off x="4303450" y="1591342"/>
+              <a:ext cx="287334" cy="0"/>
+            </a:xfrm>
+            <a:prstGeom prst="straightConnector1">
+              <a:avLst/>
+            </a:prstGeom>
+            <a:ln>
+              <a:solidFill>
+                <a:schemeClr val="tx1">
+                  <a:lumMod val="85000"/>
+                  <a:lumOff val="15000"/>
+                </a:schemeClr>
+              </a:solidFill>
+              <a:tailEnd type="triangle"/>
+            </a:ln>
+          </p:spPr>
+          <p:style>
+            <a:lnRef idx="1">
+              <a:schemeClr val="accent1"/>
+            </a:lnRef>
+            <a:fillRef idx="0">
+              <a:schemeClr val="accent1"/>
+            </a:fillRef>
+            <a:effectRef idx="0">
+              <a:schemeClr val="accent1"/>
+            </a:effectRef>
+            <a:fontRef idx="minor">
+              <a:schemeClr val="tx1"/>
+            </a:fontRef>
+          </p:style>
+        </p:cxnSp>
+        <p:cxnSp>
+          <p:nvCxnSpPr>
+            <p:cNvPr id="100" name="Connector: Elbow 99">
+              <a:extLst>
+                <a:ext uri="{FF2B5EF4-FFF2-40B4-BE49-F238E27FC236}">
+                  <a16:creationId xmlns:a16="http://schemas.microsoft.com/office/drawing/2014/main" id="{DA48E9B8-0401-4737-98CC-2DB3CFEC8901}"/>
+                </a:ext>
+              </a:extLst>
+            </p:cNvPr>
+            <p:cNvCxnSpPr>
+              <a:cxnSpLocks/>
+              <a:stCxn id="7" idx="3"/>
+              <a:endCxn id="104" idx="1"/>
+            </p:cNvCxnSpPr>
+            <p:nvPr/>
+          </p:nvCxnSpPr>
+          <p:spPr>
+            <a:xfrm>
+              <a:off x="2615624" y="1435095"/>
+              <a:ext cx="347168" cy="325937"/>
+            </a:xfrm>
+            <a:prstGeom prst="bentConnector3">
+              <a:avLst/>
+            </a:prstGeom>
+            <a:ln w="9525">
+              <a:tailEnd type="triangle"/>
+            </a:ln>
+          </p:spPr>
+          <p:style>
+            <a:lnRef idx="2">
+              <a:schemeClr val="dk1"/>
+            </a:lnRef>
+            <a:fillRef idx="0">
+              <a:schemeClr val="dk1"/>
+            </a:fillRef>
+            <a:effectRef idx="1">
+              <a:schemeClr val="dk1"/>
+            </a:effectRef>
+            <a:fontRef idx="minor">
+              <a:schemeClr val="tx1"/>
+            </a:fontRef>
+          </p:style>
+        </p:cxnSp>
+        <p:cxnSp>
+          <p:nvCxnSpPr>
+            <p:cNvPr id="102" name="Connector: Elbow 101">
+              <a:extLst>
+                <a:ext uri="{FF2B5EF4-FFF2-40B4-BE49-F238E27FC236}">
+                  <a16:creationId xmlns:a16="http://schemas.microsoft.com/office/drawing/2014/main" id="{9323BBA6-2ACF-46F5-A8A9-869ACC2084E9}"/>
+                </a:ext>
+              </a:extLst>
+            </p:cNvPr>
+            <p:cNvCxnSpPr>
+              <a:cxnSpLocks/>
+              <a:stCxn id="6" idx="3"/>
+              <a:endCxn id="104" idx="1"/>
+            </p:cNvCxnSpPr>
+            <p:nvPr/>
+          </p:nvCxnSpPr>
+          <p:spPr>
+            <a:xfrm flipV="1">
+              <a:off x="2597093" y="1761032"/>
+              <a:ext cx="365699" cy="519553"/>
+            </a:xfrm>
+            <a:prstGeom prst="bentConnector3">
+              <a:avLst>
+                <a:gd name="adj1" fmla="val 51954"/>
+              </a:avLst>
+            </a:prstGeom>
+            <a:ln w="9525">
+              <a:tailEnd type="triangle"/>
+            </a:ln>
+          </p:spPr>
+          <p:style>
+            <a:lnRef idx="2">
+              <a:schemeClr val="dk1"/>
+            </a:lnRef>
+            <a:fillRef idx="0">
+              <a:schemeClr val="dk1"/>
+            </a:fillRef>
+            <a:effectRef idx="1">
+              <a:schemeClr val="dk1"/>
+            </a:effectRef>
+            <a:fontRef idx="minor">
+              <a:schemeClr val="tx1"/>
+            </a:fontRef>
+          </p:style>
+        </p:cxnSp>
+        <p:sp>
+          <p:nvSpPr>
+            <p:cNvPr id="104" name="Rectangle 103">
+              <a:extLst>
+                <a:ext uri="{FF2B5EF4-FFF2-40B4-BE49-F238E27FC236}">
+                  <a16:creationId xmlns:a16="http://schemas.microsoft.com/office/drawing/2014/main" id="{5209C1E7-4BA0-4917-A84C-E722F35D1854}"/>
+                </a:ext>
+              </a:extLst>
+            </p:cNvPr>
+            <p:cNvSpPr/>
+            <p:nvPr/>
+          </p:nvSpPr>
+          <p:spPr>
+            <a:xfrm>
+              <a:off x="2962792" y="1738172"/>
+              <a:ext cx="45719" cy="45719"/>
+            </a:xfrm>
+            <a:prstGeom prst="rect">
+              <a:avLst/>
+            </a:prstGeom>
+            <a:noFill/>
+            <a:ln w="3175">
+              <a:noFill/>
+            </a:ln>
+          </p:spPr>
+          <p:style>
+            <a:lnRef idx="2">
+              <a:schemeClr val="accent1">
+                <a:shade val="50000"/>
+              </a:schemeClr>
+            </a:lnRef>
+            <a:fillRef idx="1">
+              <a:schemeClr val="accent1"/>
+            </a:fillRef>
+            <a:effectRef idx="0">
+              <a:schemeClr val="accent1"/>
+            </a:effectRef>
+            <a:fontRef idx="minor">
+              <a:schemeClr val="lt1"/>
+            </a:fontRef>
+          </p:style>
+          <p:txBody>
+            <a:bodyPr rtlCol="0" anchor="ctr"/>
+            <a:lstStyle/>
+            <a:p>
+              <a:pPr algn="ctr"/>
+              <a:endParaRPr lang="en-GB"/>
+            </a:p>
+          </p:txBody>
+        </p:sp>
+        <p:sp>
+          <p:nvSpPr>
+            <p:cNvPr id="111" name="Rectangle 110">
+              <a:extLst>
+                <a:ext uri="{FF2B5EF4-FFF2-40B4-BE49-F238E27FC236}">
+                  <a16:creationId xmlns:a16="http://schemas.microsoft.com/office/drawing/2014/main" id="{E7E05B8D-4A8B-4C61-A749-56851A66FBE4}"/>
+                </a:ext>
+              </a:extLst>
+            </p:cNvPr>
+            <p:cNvSpPr/>
+            <p:nvPr/>
+          </p:nvSpPr>
+          <p:spPr>
+            <a:xfrm>
+              <a:off x="1879989" y="2540487"/>
+              <a:ext cx="45719" cy="45719"/>
+            </a:xfrm>
+            <a:prstGeom prst="rect">
+              <a:avLst/>
+            </a:prstGeom>
+            <a:noFill/>
+            <a:ln w="3175">
+              <a:noFill/>
+            </a:ln>
+          </p:spPr>
+          <p:style>
+            <a:lnRef idx="2">
+              <a:schemeClr val="accent1">
+                <a:shade val="50000"/>
+              </a:schemeClr>
+            </a:lnRef>
+            <a:fillRef idx="1">
+              <a:schemeClr val="accent1"/>
+            </a:fillRef>
+            <a:effectRef idx="0">
+              <a:schemeClr val="accent1"/>
+            </a:effectRef>
+            <a:fontRef idx="minor">
+              <a:schemeClr val="lt1"/>
+            </a:fontRef>
+          </p:style>
+          <p:txBody>
+            <a:bodyPr rtlCol="0" anchor="ctr"/>
+            <a:lstStyle/>
+            <a:p>
+              <a:pPr algn="ctr"/>
+              <a:endParaRPr lang="en-GB"/>
+            </a:p>
+          </p:txBody>
+        </p:sp>
+        <p:cxnSp>
+          <p:nvCxnSpPr>
+            <p:cNvPr id="115" name="Connector: Elbow 114">
+              <a:extLst>
+                <a:ext uri="{FF2B5EF4-FFF2-40B4-BE49-F238E27FC236}">
+                  <a16:creationId xmlns:a16="http://schemas.microsoft.com/office/drawing/2014/main" id="{E8322900-7132-4B2A-9D44-B08581CDA849}"/>
+                </a:ext>
+              </a:extLst>
+            </p:cNvPr>
+            <p:cNvCxnSpPr>
+              <a:stCxn id="9" idx="3"/>
+              <a:endCxn id="15" idx="1"/>
+            </p:cNvCxnSpPr>
+            <p:nvPr/>
+          </p:nvCxnSpPr>
+          <p:spPr>
+            <a:xfrm flipV="1">
+              <a:off x="2658021" y="2959386"/>
+              <a:ext cx="317620" cy="314397"/>
+            </a:xfrm>
+            <a:prstGeom prst="bentConnector3">
+              <a:avLst>
+                <a:gd name="adj1" fmla="val 50000"/>
+              </a:avLst>
+            </a:prstGeom>
+            <a:ln>
+              <a:solidFill>
+                <a:schemeClr val="tx1"/>
+              </a:solidFill>
+              <a:tailEnd type="triangle"/>
+            </a:ln>
+          </p:spPr>
+          <p:style>
+            <a:lnRef idx="1">
+              <a:schemeClr val="accent1"/>
+            </a:lnRef>
+            <a:fillRef idx="0">
+              <a:schemeClr val="accent1"/>
+            </a:fillRef>
+            <a:effectRef idx="0">
+              <a:schemeClr val="accent1"/>
+            </a:effectRef>
+            <a:fontRef idx="minor">
+              <a:schemeClr val="tx1"/>
+            </a:fontRef>
+          </p:style>
+        </p:cxnSp>
+      </p:grpSp>
+    </p:spTree>
+    <p:extLst>
+      <p:ext uri="{BB962C8B-B14F-4D97-AF65-F5344CB8AC3E}">
+        <p14:creationId xmlns:p14="http://schemas.microsoft.com/office/powerpoint/2010/main" val="4242589315"/>
+      </p:ext>
+    </p:extLst>
+  </p:cSld>
+  <p:clrMapOvr>
+    <a:masterClrMapping/>
+  </p:clrMapOvr>
+</p:sld>
+</file>
+
 <file path=ppt/theme/theme1.xml><?xml version="1.0" encoding="utf-8"?>
 <a:theme xmlns:a="http://schemas.openxmlformats.org/drawingml/2006/main" name="Office Theme">
   <a:themeElements>

</xml_diff>

<commit_message>
Updated calibration of allocation parameters and spatial prob perturbation process
</commit_message>
<xml_diff>
--- a/publication/lulcc_ch_visualisations.pptx
+++ b/publication/lulcc_ch_visualisations.pptx
@@ -264,7 +264,7 @@
           <a:p>
             <a:fld id="{38A02E74-1BEC-4682-B539-13A15FE70A36}" type="datetimeFigureOut">
               <a:rPr lang="en-GB" smtClean="0"/>
-              <a:t>11/01/2023</a:t>
+              <a:t>08/03/2023</a:t>
             </a:fld>
             <a:endParaRPr lang="en-GB"/>
           </a:p>
@@ -434,7 +434,7 @@
           <a:p>
             <a:fld id="{38A02E74-1BEC-4682-B539-13A15FE70A36}" type="datetimeFigureOut">
               <a:rPr lang="en-GB" smtClean="0"/>
-              <a:t>11/01/2023</a:t>
+              <a:t>08/03/2023</a:t>
             </a:fld>
             <a:endParaRPr lang="en-GB"/>
           </a:p>
@@ -614,7 +614,7 @@
           <a:p>
             <a:fld id="{38A02E74-1BEC-4682-B539-13A15FE70A36}" type="datetimeFigureOut">
               <a:rPr lang="en-GB" smtClean="0"/>
-              <a:t>11/01/2023</a:t>
+              <a:t>08/03/2023</a:t>
             </a:fld>
             <a:endParaRPr lang="en-GB"/>
           </a:p>
@@ -784,7 +784,7 @@
           <a:p>
             <a:fld id="{38A02E74-1BEC-4682-B539-13A15FE70A36}" type="datetimeFigureOut">
               <a:rPr lang="en-GB" smtClean="0"/>
-              <a:t>11/01/2023</a:t>
+              <a:t>08/03/2023</a:t>
             </a:fld>
             <a:endParaRPr lang="en-GB"/>
           </a:p>
@@ -1028,7 +1028,7 @@
           <a:p>
             <a:fld id="{38A02E74-1BEC-4682-B539-13A15FE70A36}" type="datetimeFigureOut">
               <a:rPr lang="en-GB" smtClean="0"/>
-              <a:t>11/01/2023</a:t>
+              <a:t>08/03/2023</a:t>
             </a:fld>
             <a:endParaRPr lang="en-GB"/>
           </a:p>
@@ -1260,7 +1260,7 @@
           <a:p>
             <a:fld id="{38A02E74-1BEC-4682-B539-13A15FE70A36}" type="datetimeFigureOut">
               <a:rPr lang="en-GB" smtClean="0"/>
-              <a:t>11/01/2023</a:t>
+              <a:t>08/03/2023</a:t>
             </a:fld>
             <a:endParaRPr lang="en-GB"/>
           </a:p>
@@ -1627,7 +1627,7 @@
           <a:p>
             <a:fld id="{38A02E74-1BEC-4682-B539-13A15FE70A36}" type="datetimeFigureOut">
               <a:rPr lang="en-GB" smtClean="0"/>
-              <a:t>11/01/2023</a:t>
+              <a:t>08/03/2023</a:t>
             </a:fld>
             <a:endParaRPr lang="en-GB"/>
           </a:p>
@@ -1745,7 +1745,7 @@
           <a:p>
             <a:fld id="{38A02E74-1BEC-4682-B539-13A15FE70A36}" type="datetimeFigureOut">
               <a:rPr lang="en-GB" smtClean="0"/>
-              <a:t>11/01/2023</a:t>
+              <a:t>08/03/2023</a:t>
             </a:fld>
             <a:endParaRPr lang="en-GB"/>
           </a:p>
@@ -1840,7 +1840,7 @@
           <a:p>
             <a:fld id="{38A02E74-1BEC-4682-B539-13A15FE70A36}" type="datetimeFigureOut">
               <a:rPr lang="en-GB" smtClean="0"/>
-              <a:t>11/01/2023</a:t>
+              <a:t>08/03/2023</a:t>
             </a:fld>
             <a:endParaRPr lang="en-GB"/>
           </a:p>
@@ -2117,7 +2117,7 @@
           <a:p>
             <a:fld id="{38A02E74-1BEC-4682-B539-13A15FE70A36}" type="datetimeFigureOut">
               <a:rPr lang="en-GB" smtClean="0"/>
-              <a:t>11/01/2023</a:t>
+              <a:t>08/03/2023</a:t>
             </a:fld>
             <a:endParaRPr lang="en-GB"/>
           </a:p>
@@ -2374,7 +2374,7 @@
           <a:p>
             <a:fld id="{38A02E74-1BEC-4682-B539-13A15FE70A36}" type="datetimeFigureOut">
               <a:rPr lang="en-GB" smtClean="0"/>
-              <a:t>11/01/2023</a:t>
+              <a:t>08/03/2023</a:t>
             </a:fld>
             <a:endParaRPr lang="en-GB"/>
           </a:p>
@@ -2587,7 +2587,7 @@
           <a:p>
             <a:fld id="{38A02E74-1BEC-4682-B539-13A15FE70A36}" type="datetimeFigureOut">
               <a:rPr lang="en-GB" smtClean="0"/>
-              <a:t>11/01/2023</a:t>
+              <a:t>08/03/2023</a:t>
             </a:fld>
             <a:endParaRPr lang="en-GB"/>
           </a:p>
@@ -6656,15 +6656,15 @@
                   </p:cNvPr>
                   <p:cNvCxnSpPr>
                     <a:cxnSpLocks/>
-                    <a:stCxn id="6" idx="2"/>
-                    <a:endCxn id="98" idx="0"/>
+                    <a:stCxn id="9" idx="0"/>
+                    <a:endCxn id="6" idx="2"/>
                   </p:cNvCxnSpPr>
                   <p:nvPr/>
                 </p:nvCxnSpPr>
                 <p:spPr>
-                  <a:xfrm>
+                  <a:xfrm flipH="1" flipV="1">
                     <a:off x="1577087" y="2407596"/>
-                    <a:ext cx="2155" cy="218201"/>
+                    <a:ext cx="1077" cy="212660"/>
                   </a:xfrm>
                   <a:prstGeom prst="straightConnector1">
                     <a:avLst/>
@@ -8023,6 +8023,224 @@
           </a:p>
         </p:txBody>
       </p:sp>
+      <p:cxnSp>
+        <p:nvCxnSpPr>
+          <p:cNvPr id="43" name="Connector: Elbow 42">
+            <a:extLst>
+              <a:ext uri="{FF2B5EF4-FFF2-40B4-BE49-F238E27FC236}">
+                <a16:creationId xmlns:a16="http://schemas.microsoft.com/office/drawing/2014/main" id="{44E05DE4-6240-4D04-91E9-38151133E3F3}"/>
+              </a:ext>
+            </a:extLst>
+          </p:cNvPr>
+          <p:cNvCxnSpPr>
+            <a:cxnSpLocks/>
+            <a:stCxn id="9" idx="2"/>
+            <a:endCxn id="58" idx="1"/>
+          </p:cNvCxnSpPr>
+          <p:nvPr/>
+        </p:nvCxnSpPr>
+        <p:spPr>
+          <a:xfrm rot="16200000" flipH="1">
+            <a:off x="2520870" y="4486416"/>
+            <a:ext cx="1162661" cy="1014651"/>
+          </a:xfrm>
+          <a:prstGeom prst="bentConnector2">
+            <a:avLst/>
+          </a:prstGeom>
+          <a:ln>
+            <a:solidFill>
+              <a:schemeClr val="tx1">
+                <a:lumMod val="85000"/>
+                <a:lumOff val="15000"/>
+              </a:schemeClr>
+            </a:solidFill>
+            <a:tailEnd type="triangle"/>
+          </a:ln>
+        </p:spPr>
+        <p:style>
+          <a:lnRef idx="1">
+            <a:schemeClr val="accent1"/>
+          </a:lnRef>
+          <a:fillRef idx="0">
+            <a:schemeClr val="accent1"/>
+          </a:fillRef>
+          <a:effectRef idx="0">
+            <a:schemeClr val="accent1"/>
+          </a:effectRef>
+          <a:fontRef idx="minor">
+            <a:schemeClr val="tx1"/>
+          </a:fontRef>
+        </p:style>
+      </p:cxnSp>
+      <p:sp>
+        <p:nvSpPr>
+          <p:cNvPr id="46" name="Flowchart: Process 45">
+            <a:extLst>
+              <a:ext uri="{FF2B5EF4-FFF2-40B4-BE49-F238E27FC236}">
+                <a16:creationId xmlns:a16="http://schemas.microsoft.com/office/drawing/2014/main" id="{EF34E1D1-6A49-450D-AC20-FCAEC0EC43F2}"/>
+              </a:ext>
+            </a:extLst>
+          </p:cNvPr>
+          <p:cNvSpPr/>
+          <p:nvPr/>
+        </p:nvSpPr>
+        <p:spPr>
+          <a:xfrm flipH="1">
+            <a:off x="3632821" y="6155755"/>
+            <a:ext cx="1257436" cy="478642"/>
+          </a:xfrm>
+          <a:prstGeom prst="flowChartProcess">
+            <a:avLst/>
+          </a:prstGeom>
+          <a:solidFill>
+            <a:schemeClr val="bg1"/>
+          </a:solidFill>
+          <a:ln>
+            <a:solidFill>
+              <a:schemeClr val="tx1"/>
+            </a:solidFill>
+            <a:prstDash val="solid"/>
+          </a:ln>
+        </p:spPr>
+        <p:style>
+          <a:lnRef idx="2">
+            <a:schemeClr val="accent1">
+              <a:shade val="50000"/>
+            </a:schemeClr>
+          </a:lnRef>
+          <a:fillRef idx="1">
+            <a:schemeClr val="accent1"/>
+          </a:fillRef>
+          <a:effectRef idx="0">
+            <a:schemeClr val="accent1"/>
+          </a:effectRef>
+          <a:fontRef idx="minor">
+            <a:schemeClr val="lt1"/>
+          </a:fontRef>
+        </p:style>
+        <p:txBody>
+          <a:bodyPr rtlCol="0" anchor="ctr"/>
+          <a:lstStyle/>
+          <a:p>
+            <a:pPr algn="ctr"/>
+            <a:r>
+              <a:rPr lang="en-US" sz="1200" dirty="0">
+                <a:solidFill>
+                  <a:schemeClr val="tx1"/>
+                </a:solidFill>
+                <a:latin typeface="Lato Light" panose="020F0502020204030203" pitchFamily="34" charset="0"/>
+                <a:ea typeface="Lato Light" panose="020F0502020204030203" pitchFamily="34" charset="0"/>
+                <a:cs typeface="Lato Light" panose="020F0502020204030203" pitchFamily="34" charset="0"/>
+              </a:rPr>
+              <a:t>Parameter calibration</a:t>
+            </a:r>
+            <a:endParaRPr lang="en-GB" sz="1200" dirty="0">
+              <a:solidFill>
+                <a:schemeClr val="tx1"/>
+              </a:solidFill>
+              <a:latin typeface="Lato Light" panose="020F0502020204030203" pitchFamily="34" charset="0"/>
+              <a:ea typeface="Lato Light" panose="020F0502020204030203" pitchFamily="34" charset="0"/>
+              <a:cs typeface="Lato Light" panose="020F0502020204030203" pitchFamily="34" charset="0"/>
+            </a:endParaRPr>
+          </a:p>
+        </p:txBody>
+      </p:sp>
+      <p:cxnSp>
+        <p:nvCxnSpPr>
+          <p:cNvPr id="47" name="Straight Arrow Connector 46">
+            <a:extLst>
+              <a:ext uri="{FF2B5EF4-FFF2-40B4-BE49-F238E27FC236}">
+                <a16:creationId xmlns:a16="http://schemas.microsoft.com/office/drawing/2014/main" id="{0DBF3AD2-1DA0-4602-BF86-E485413714A9}"/>
+              </a:ext>
+            </a:extLst>
+          </p:cNvPr>
+          <p:cNvCxnSpPr>
+            <a:cxnSpLocks/>
+            <a:stCxn id="46" idx="1"/>
+          </p:cNvCxnSpPr>
+          <p:nvPr/>
+        </p:nvCxnSpPr>
+        <p:spPr>
+          <a:xfrm>
+            <a:off x="4890257" y="6395076"/>
+            <a:ext cx="410570" cy="1"/>
+          </a:xfrm>
+          <a:prstGeom prst="straightConnector1">
+            <a:avLst/>
+          </a:prstGeom>
+          <a:ln>
+            <a:solidFill>
+              <a:schemeClr val="tx1">
+                <a:lumMod val="85000"/>
+                <a:lumOff val="15000"/>
+              </a:schemeClr>
+            </a:solidFill>
+            <a:tailEnd type="triangle"/>
+          </a:ln>
+        </p:spPr>
+        <p:style>
+          <a:lnRef idx="1">
+            <a:schemeClr val="accent1"/>
+          </a:lnRef>
+          <a:fillRef idx="0">
+            <a:schemeClr val="accent1"/>
+          </a:fillRef>
+          <a:effectRef idx="0">
+            <a:schemeClr val="accent1"/>
+          </a:effectRef>
+          <a:fontRef idx="minor">
+            <a:schemeClr val="tx1"/>
+          </a:fontRef>
+        </p:style>
+      </p:cxnSp>
+      <p:cxnSp>
+        <p:nvCxnSpPr>
+          <p:cNvPr id="48" name="Straight Arrow Connector 47">
+            <a:extLst>
+              <a:ext uri="{FF2B5EF4-FFF2-40B4-BE49-F238E27FC236}">
+                <a16:creationId xmlns:a16="http://schemas.microsoft.com/office/drawing/2014/main" id="{8A8E014C-F088-40AE-9717-608A28A09CA2}"/>
+              </a:ext>
+            </a:extLst>
+          </p:cNvPr>
+          <p:cNvCxnSpPr>
+            <a:cxnSpLocks/>
+            <a:stCxn id="46" idx="0"/>
+          </p:cNvCxnSpPr>
+          <p:nvPr/>
+        </p:nvCxnSpPr>
+        <p:spPr>
+          <a:xfrm flipV="1">
+            <a:off x="4261539" y="5810431"/>
+            <a:ext cx="0" cy="345324"/>
+          </a:xfrm>
+          <a:prstGeom prst="straightConnector1">
+            <a:avLst/>
+          </a:prstGeom>
+          <a:ln>
+            <a:solidFill>
+              <a:schemeClr val="tx1">
+                <a:lumMod val="85000"/>
+                <a:lumOff val="15000"/>
+              </a:schemeClr>
+            </a:solidFill>
+            <a:tailEnd type="triangle"/>
+          </a:ln>
+        </p:spPr>
+        <p:style>
+          <a:lnRef idx="1">
+            <a:schemeClr val="accent1"/>
+          </a:lnRef>
+          <a:fillRef idx="0">
+            <a:schemeClr val="accent1"/>
+          </a:fillRef>
+          <a:effectRef idx="0">
+            <a:schemeClr val="accent1"/>
+          </a:effectRef>
+          <a:fontRef idx="minor">
+            <a:schemeClr val="tx1"/>
+          </a:fontRef>
+        </p:style>
+      </p:cxnSp>
     </p:spTree>
     <p:extLst>
       <p:ext uri="{BB962C8B-B14F-4D97-AF65-F5344CB8AC3E}">

</xml_diff>

<commit_message>
All scripts following first complete run of simulations
</commit_message>
<xml_diff>
--- a/publication/lulcc_ch_visualisations.pptx
+++ b/publication/lulcc_ch_visualisations.pptx
@@ -264,7 +264,7 @@
           <a:p>
             <a:fld id="{38A02E74-1BEC-4682-B539-13A15FE70A36}" type="datetimeFigureOut">
               <a:rPr lang="en-GB" smtClean="0"/>
-              <a:t>08/03/2023</a:t>
+              <a:t>02/05/2023</a:t>
             </a:fld>
             <a:endParaRPr lang="en-GB"/>
           </a:p>
@@ -434,7 +434,7 @@
           <a:p>
             <a:fld id="{38A02E74-1BEC-4682-B539-13A15FE70A36}" type="datetimeFigureOut">
               <a:rPr lang="en-GB" smtClean="0"/>
-              <a:t>08/03/2023</a:t>
+              <a:t>02/05/2023</a:t>
             </a:fld>
             <a:endParaRPr lang="en-GB"/>
           </a:p>
@@ -614,7 +614,7 @@
           <a:p>
             <a:fld id="{38A02E74-1BEC-4682-B539-13A15FE70A36}" type="datetimeFigureOut">
               <a:rPr lang="en-GB" smtClean="0"/>
-              <a:t>08/03/2023</a:t>
+              <a:t>02/05/2023</a:t>
             </a:fld>
             <a:endParaRPr lang="en-GB"/>
           </a:p>
@@ -784,7 +784,7 @@
           <a:p>
             <a:fld id="{38A02E74-1BEC-4682-B539-13A15FE70A36}" type="datetimeFigureOut">
               <a:rPr lang="en-GB" smtClean="0"/>
-              <a:t>08/03/2023</a:t>
+              <a:t>02/05/2023</a:t>
             </a:fld>
             <a:endParaRPr lang="en-GB"/>
           </a:p>
@@ -1028,7 +1028,7 @@
           <a:p>
             <a:fld id="{38A02E74-1BEC-4682-B539-13A15FE70A36}" type="datetimeFigureOut">
               <a:rPr lang="en-GB" smtClean="0"/>
-              <a:t>08/03/2023</a:t>
+              <a:t>02/05/2023</a:t>
             </a:fld>
             <a:endParaRPr lang="en-GB"/>
           </a:p>
@@ -1260,7 +1260,7 @@
           <a:p>
             <a:fld id="{38A02E74-1BEC-4682-B539-13A15FE70A36}" type="datetimeFigureOut">
               <a:rPr lang="en-GB" smtClean="0"/>
-              <a:t>08/03/2023</a:t>
+              <a:t>02/05/2023</a:t>
             </a:fld>
             <a:endParaRPr lang="en-GB"/>
           </a:p>
@@ -1627,7 +1627,7 @@
           <a:p>
             <a:fld id="{38A02E74-1BEC-4682-B539-13A15FE70A36}" type="datetimeFigureOut">
               <a:rPr lang="en-GB" smtClean="0"/>
-              <a:t>08/03/2023</a:t>
+              <a:t>02/05/2023</a:t>
             </a:fld>
             <a:endParaRPr lang="en-GB"/>
           </a:p>
@@ -1745,7 +1745,7 @@
           <a:p>
             <a:fld id="{38A02E74-1BEC-4682-B539-13A15FE70A36}" type="datetimeFigureOut">
               <a:rPr lang="en-GB" smtClean="0"/>
-              <a:t>08/03/2023</a:t>
+              <a:t>02/05/2023</a:t>
             </a:fld>
             <a:endParaRPr lang="en-GB"/>
           </a:p>
@@ -1840,7 +1840,7 @@
           <a:p>
             <a:fld id="{38A02E74-1BEC-4682-B539-13A15FE70A36}" type="datetimeFigureOut">
               <a:rPr lang="en-GB" smtClean="0"/>
-              <a:t>08/03/2023</a:t>
+              <a:t>02/05/2023</a:t>
             </a:fld>
             <a:endParaRPr lang="en-GB"/>
           </a:p>
@@ -2117,7 +2117,7 @@
           <a:p>
             <a:fld id="{38A02E74-1BEC-4682-B539-13A15FE70A36}" type="datetimeFigureOut">
               <a:rPr lang="en-GB" smtClean="0"/>
-              <a:t>08/03/2023</a:t>
+              <a:t>02/05/2023</a:t>
             </a:fld>
             <a:endParaRPr lang="en-GB"/>
           </a:p>
@@ -2374,7 +2374,7 @@
           <a:p>
             <a:fld id="{38A02E74-1BEC-4682-B539-13A15FE70A36}" type="datetimeFigureOut">
               <a:rPr lang="en-GB" smtClean="0"/>
-              <a:t>08/03/2023</a:t>
+              <a:t>02/05/2023</a:t>
             </a:fld>
             <a:endParaRPr lang="en-GB"/>
           </a:p>
@@ -2587,7 +2587,7 @@
           <a:p>
             <a:fld id="{38A02E74-1BEC-4682-B539-13A15FE70A36}" type="datetimeFigureOut">
               <a:rPr lang="en-GB" smtClean="0"/>
-              <a:t>08/03/2023</a:t>
+              <a:t>02/05/2023</a:t>
             </a:fld>
             <a:endParaRPr lang="en-GB"/>
           </a:p>
@@ -8147,23 +8147,23 @@
       </p:sp>
       <p:cxnSp>
         <p:nvCxnSpPr>
-          <p:cNvPr id="47" name="Straight Arrow Connector 46">
+          <p:cNvPr id="48" name="Straight Arrow Connector 47">
             <a:extLst>
               <a:ext uri="{FF2B5EF4-FFF2-40B4-BE49-F238E27FC236}">
-                <a16:creationId xmlns:a16="http://schemas.microsoft.com/office/drawing/2014/main" id="{0DBF3AD2-1DA0-4602-BF86-E485413714A9}"/>
+                <a16:creationId xmlns:a16="http://schemas.microsoft.com/office/drawing/2014/main" id="{8A8E014C-F088-40AE-9717-608A28A09CA2}"/>
               </a:ext>
             </a:extLst>
           </p:cNvPr>
           <p:cNvCxnSpPr>
             <a:cxnSpLocks/>
-            <a:stCxn id="46" idx="1"/>
+            <a:stCxn id="46" idx="0"/>
           </p:cNvCxnSpPr>
           <p:nvPr/>
         </p:nvCxnSpPr>
         <p:spPr>
-          <a:xfrm>
-            <a:off x="4890257" y="6395076"/>
-            <a:ext cx="410570" cy="1"/>
+          <a:xfrm flipV="1">
+            <a:off x="4261539" y="5810431"/>
+            <a:ext cx="0" cy="345324"/>
           </a:xfrm>
           <a:prstGeom prst="straightConnector1">
             <a:avLst/>
@@ -8195,26 +8195,29 @@
       </p:cxnSp>
       <p:cxnSp>
         <p:nvCxnSpPr>
-          <p:cNvPr id="48" name="Straight Arrow Connector 47">
+          <p:cNvPr id="19" name="Connector: Elbow 18">
             <a:extLst>
               <a:ext uri="{FF2B5EF4-FFF2-40B4-BE49-F238E27FC236}">
-                <a16:creationId xmlns:a16="http://schemas.microsoft.com/office/drawing/2014/main" id="{8A8E014C-F088-40AE-9717-608A28A09CA2}"/>
+                <a16:creationId xmlns:a16="http://schemas.microsoft.com/office/drawing/2014/main" id="{D4A54499-F69E-488B-9022-95DCCD26F965}"/>
               </a:ext>
             </a:extLst>
           </p:cNvPr>
           <p:cNvCxnSpPr>
             <a:cxnSpLocks/>
-            <a:stCxn id="46" idx="0"/>
+            <a:stCxn id="33" idx="1"/>
+            <a:endCxn id="46" idx="3"/>
           </p:cNvCxnSpPr>
           <p:nvPr/>
         </p:nvCxnSpPr>
         <p:spPr>
-          <a:xfrm flipV="1">
-            <a:off x="4261539" y="5810431"/>
-            <a:ext cx="0" cy="345324"/>
+          <a:xfrm rot="10800000" flipV="1">
+            <a:off x="3632821" y="1028042"/>
+            <a:ext cx="93540" cy="5367033"/>
           </a:xfrm>
-          <a:prstGeom prst="straightConnector1">
-            <a:avLst/>
+          <a:prstGeom prst="bentConnector3">
+            <a:avLst>
+              <a:gd name="adj1" fmla="val 2200835"/>
+            </a:avLst>
           </a:prstGeom>
           <a:ln>
             <a:solidFill>

</xml_diff>